<commit_message>
Align slide 1 hero metric: net new alerts/month at peak, for both themes
</commit_message>
<xml_diff>
--- a/deck-2026/build/dataminr_2026_alerting_summary.pptx
+++ b/deck-2026/build/dataminr_2026_alerting_summary.pptx
@@ -3350,7 +3350,7 @@
                 </a:solidFill>
                 <a:latin typeface="Noto Sans"/>
               </a:rPr>
-              <a:t>GROWTH, MAY 2025 -&gt; MAR 2026</a:t>
+              <a:t>NET NEW ALERTS/MONTH, AT PEAK</a:t>
             </a:r>
           </a:p>
         </p:txBody>
@@ -3384,7 +3384,7 @@
                 </a:solidFill>
                 <a:latin typeface="Archivo"/>
               </a:rPr>
-              <a:t>~59x</a:t>
+              <a:t>13,351</a:t>
             </a:r>
           </a:p>
         </p:txBody>
@@ -3418,7 +3418,7 @@
                 </a:solidFill>
                 <a:latin typeface="Noto Sans"/>
               </a:rPr>
-              <a:t>13,351 alerts at peak (Mar 2026), up from 228</a:t>
+              <a:t>Mar 2026 -- up from zero a year earlier</a:t>
             </a:r>
           </a:p>
         </p:txBody>
@@ -4621,7 +4621,7 @@
                 </a:solidFill>
                 <a:latin typeface="Noto Sans"/>
               </a:rPr>
-              <a:t>PEAK MONTHLY ALERTS</a:t>
+              <a:t>NET NEW ALERTS/MONTH, AT PEAK</a:t>
             </a:r>
           </a:p>
         </p:txBody>
@@ -4689,7 +4689,7 @@
                 </a:solidFill>
                 <a:latin typeface="Noto Sans"/>
               </a:rPr>
-              <a:t>Up from zero in Feb 2026 -- stood up for Epic Fury</a:t>
+              <a:t>Jul 2026 -- up from zero in February</a:t>
             </a:r>
           </a:p>
         </p:txBody>

</xml_diff>